<commit_message>
Minimalise the deck, fix its word spacing, and correct the README
The word spacing was the template's justification. It suits the long
paragraphs the placeholders were written for and ruins short bullets:
justification stretches a one-line bullet across the full slide width and opens
rivers of white space between the words. Every body paragraph, including the
title page fields, is left-aligned now, so word spacing is even.

The content is cut to one line per bullet - ten on the solution slide, seven on
impact - with larger type and per-slide spacing, so a sparse slide can breathe
without a dense one overflowing. The idea title is one line and stops clear of
the SIH banner rather than running under it.

README: the interface section had a half-applied edit leaving a stale sentence
and a faculty row that predated Marks, upload, publish and delete. Test count,
auto-release figure, and the current known gaps are correct again.
</commit_message>
<xml_diff>
--- a/presentation/SIH2026-EvalPro-Idea-Presentation.pptx
+++ b/presentation/SIH2026-EvalPro-Idea-Presentation.pptx
@@ -5644,18 +5644,18 @@
           <a:bodyPr wrap="square" rtlCol="0" lIns="45720" rIns="45720" tIns="22860" bIns="22860"/>
           <a:lstStyle/>
           <a:p>
-            <a:pPr algn="just" marL="219456" indent="-219456">
+            <a:pPr algn="l" marL="219456" indent="-219456">
               <a:lnSpc>
-                <a:spcPct val="114999"/>
+                <a:spcPct val="112000"/>
               </a:lnSpc>
               <a:buFont typeface="Arial" pitchFamily="34" charset="0"/>
               <a:buChar char="•"/>
               <a:spcAft>
-                <a:spcPts val="1200"/>
+                <a:spcPts val="1400"/>
               </a:spcAft>
             </a:pPr>
             <a:r>
-              <a:rPr sz="1500" b="1" i="0" u="none">
+              <a:rPr sz="1550" b="1" i="0" u="none">
                 <a:solidFill>
                   <a:srgbClr val="1A1A1A"/>
                 </a:solidFill>
@@ -5665,7 +5665,7 @@
               <a:t>Problem Statement ID – </a:t>
             </a:r>
             <a:r>
-              <a:rPr sz="1500" b="0" i="0" u="none">
+              <a:rPr sz="1550" b="0" i="0" u="none">
                 <a:solidFill>
                   <a:srgbClr val="1F497D"/>
                 </a:solidFill>
@@ -5677,18 +5677,18 @@
             <a:endParaRPr lang="en-US" dirty="0"/>
           </a:p>
           <a:p>
-            <a:pPr algn="just" marL="219456" indent="-219456">
+            <a:pPr algn="l" marL="219456" indent="-219456">
               <a:lnSpc>
-                <a:spcPct val="114999"/>
+                <a:spcPct val="112000"/>
               </a:lnSpc>
               <a:buFont typeface="Arial" pitchFamily="34" charset="0"/>
               <a:buChar char="•"/>
               <a:spcAft>
-                <a:spcPts val="1200"/>
+                <a:spcPts val="1400"/>
               </a:spcAft>
             </a:pPr>
             <a:r>
-              <a:rPr sz="1500" b="1" i="0" u="none">
+              <a:rPr sz="1550" b="1" i="0" u="none">
                 <a:solidFill>
                   <a:srgbClr val="1A1A1A"/>
                 </a:solidFill>
@@ -5698,7 +5698,7 @@
               <a:t>Problem Statement Title – </a:t>
             </a:r>
             <a:r>
-              <a:rPr sz="1500" b="0" i="0" u="none">
+              <a:rPr sz="1550" b="0" i="0" u="none">
                 <a:solidFill>
                   <a:srgbClr val="1F497D"/>
                 </a:solidFill>
@@ -5709,18 +5709,18 @@
             </a:r>
           </a:p>
           <a:p>
-            <a:pPr algn="just" marL="219456" indent="-219456">
+            <a:pPr algn="l" marL="219456" indent="-219456">
               <a:lnSpc>
-                <a:spcPct val="114999"/>
+                <a:spcPct val="112000"/>
               </a:lnSpc>
               <a:buFont typeface="Arial" pitchFamily="34" charset="0"/>
               <a:buChar char="•"/>
               <a:spcAft>
-                <a:spcPts val="1200"/>
+                <a:spcPts val="1400"/>
               </a:spcAft>
             </a:pPr>
             <a:r>
-              <a:rPr sz="1500" b="1" i="0" u="none">
+              <a:rPr sz="1550" b="1" i="0" u="none">
                 <a:solidFill>
                   <a:srgbClr val="1A1A1A"/>
                 </a:solidFill>
@@ -5730,7 +5730,7 @@
               <a:t>Theme – </a:t>
             </a:r>
             <a:r>
-              <a:rPr sz="1500" b="0" i="0" u="none">
+              <a:rPr sz="1550" b="0" i="0" u="none">
                 <a:solidFill>
                   <a:srgbClr val="1F497D"/>
                 </a:solidFill>
@@ -5741,18 +5741,18 @@
             </a:r>
           </a:p>
           <a:p>
-            <a:pPr algn="just" marL="219456" indent="-219456">
+            <a:pPr algn="l" marL="219456" indent="-219456">
               <a:lnSpc>
-                <a:spcPct val="114999"/>
+                <a:spcPct val="112000"/>
               </a:lnSpc>
               <a:buFont typeface="Arial" pitchFamily="34" charset="0"/>
               <a:buChar char="•"/>
               <a:spcAft>
-                <a:spcPts val="1200"/>
+                <a:spcPts val="1400"/>
               </a:spcAft>
             </a:pPr>
             <a:r>
-              <a:rPr sz="1500" b="1" i="0" u="none">
+              <a:rPr sz="1550" b="1" i="0" u="none">
                 <a:solidFill>
                   <a:srgbClr val="1A1A1A"/>
                 </a:solidFill>
@@ -5762,7 +5762,7 @@
               <a:t>PS Category – </a:t>
             </a:r>
             <a:r>
-              <a:rPr sz="1500" b="0" i="0" u="none">
+              <a:rPr sz="1550" b="0" i="0" u="none">
                 <a:solidFill>
                   <a:srgbClr val="1F497D"/>
                 </a:solidFill>
@@ -5773,18 +5773,18 @@
             </a:r>
           </a:p>
           <a:p>
-            <a:pPr algn="just" marL="219456" indent="-219456">
+            <a:pPr algn="l" marL="219456" indent="-219456">
               <a:lnSpc>
-                <a:spcPct val="114999"/>
+                <a:spcPct val="112000"/>
               </a:lnSpc>
               <a:buFont typeface="Arial" pitchFamily="34" charset="0"/>
               <a:buChar char="•"/>
               <a:spcAft>
-                <a:spcPts val="1200"/>
+                <a:spcPts val="1400"/>
               </a:spcAft>
             </a:pPr>
             <a:r>
-              <a:rPr sz="1500" b="1" i="0" u="none">
+              <a:rPr sz="1550" b="1" i="0" u="none">
                 <a:solidFill>
                   <a:srgbClr val="1A1A1A"/>
                 </a:solidFill>
@@ -5794,7 +5794,7 @@
               <a:t>Team ID – </a:t>
             </a:r>
             <a:r>
-              <a:rPr sz="1500" b="0" i="0" u="none">
+              <a:rPr sz="1550" b="0" i="0" u="none">
                 <a:solidFill>
                   <a:srgbClr val="1F497D"/>
                 </a:solidFill>
@@ -5805,18 +5805,18 @@
             </a:r>
           </a:p>
           <a:p>
-            <a:pPr algn="just" marL="219456" indent="-219456">
+            <a:pPr algn="l" marL="219456" indent="-219456">
               <a:lnSpc>
-                <a:spcPct val="114999"/>
+                <a:spcPct val="112000"/>
               </a:lnSpc>
               <a:buFont typeface="Arial" pitchFamily="34" charset="0"/>
               <a:buChar char="•"/>
               <a:spcAft>
-                <a:spcPts val="1200"/>
+                <a:spcPts val="1400"/>
               </a:spcAft>
             </a:pPr>
             <a:r>
-              <a:rPr sz="1500" b="1" i="0" u="none">
+              <a:rPr sz="1550" b="1" i="0" u="none">
                 <a:solidFill>
                   <a:srgbClr val="1A1A1A"/>
                 </a:solidFill>
@@ -5826,7 +5826,7 @@
               <a:t>Team Name (Registered on portal) – </a:t>
             </a:r>
             <a:r>
-              <a:rPr sz="1500" b="0" i="0" u="none">
+              <a:rPr sz="1550" b="0" i="0" u="none">
                 <a:solidFill>
                   <a:srgbClr val="1F497D"/>
                 </a:solidFill>
@@ -5963,8 +5963,8 @@
         </p:nvSpPr>
         <p:spPr>
           <a:xfrm>
-            <a:off x="1719072" y="91440"/>
-            <a:ext cx="7818120" cy="914400"/>
+            <a:off x="1719072" y="201168"/>
+            <a:ext cx="7973568" cy="731520"/>
           </a:xfrm>
         </p:spPr>
         <p:txBody>
@@ -5978,14 +5978,14 @@
               <a:buNone/>
             </a:pPr>
             <a:r>
-              <a:rPr sz="2700" b="1" i="0" u="none">
+              <a:rPr sz="2400" b="1" i="0" u="none">
                 <a:solidFill>
                   <a:srgbClr val="1F497D"/>
                 </a:solidFill>
                 <a:latin typeface="Times New Roman"/>
                 <a:cs typeface="Times New Roman" pitchFamily="34" charset="0"/>
               </a:rPr>
-              <a:t>EvalPro - Programming Labs That Mark Themselves, and Explain Why</a:t>
+              <a:t>EvalPro - Programming Labs That Mark Themselves</a:t>
             </a:r>
           </a:p>
         </p:txBody>
@@ -6000,8 +6000,8 @@
         </p:nvSpPr>
         <p:spPr bwMode="auto">
           <a:xfrm>
-            <a:off x="329184" y="1152144"/>
-            <a:ext cx="11503152" cy="5029200"/>
+            <a:off x="329184" y="1188720"/>
+            <a:ext cx="11503152" cy="4992624"/>
           </a:xfrm>
           <a:prstGeom prst="rect">
             <a:avLst/>
@@ -6025,7 +6025,7 @@
               <a:buFont typeface="Wingdings" pitchFamily="34" charset="0"/>
               <a:buChar char="v"/>
               <a:spcAft>
-                <a:spcPts val="1000"/>
+                <a:spcPts val="1100"/>
               </a:spcAft>
             </a:pPr>
             <a:r>
@@ -6054,14 +6054,14 @@
               <a:buFont typeface="Wingdings" pitchFamily="34" charset="0"/>
               <a:buChar char="v"/>
               <a:spcBef>
-                <a:spcPts val="700"/>
+                <a:spcPts val="2000"/>
               </a:spcBef>
               <a:spcAft>
-                <a:spcPts val="300"/>
+                <a:spcPts val="600"/>
               </a:spcAft>
             </a:pPr>
             <a:r>
-              <a:rPr sz="1700" b="1" i="0" u="sng">
+              <a:rPr sz="1800" b="1" i="0" u="sng">
                 <a:solidFill>
                   <a:srgbClr val="1F497D"/>
                 </a:solidFill>
@@ -6072,69 +6072,69 @@
             </a:r>
           </a:p>
           <a:p>
-            <a:pPr algn="just" marL="329184" indent="-219456">
+            <a:pPr algn="l" marL="329184" indent="-219456">
               <a:lnSpc>
-                <a:spcPct val="95000"/>
+                <a:spcPct val="112000"/>
               </a:lnSpc>
               <a:buFont typeface="Arial" pitchFamily="34" charset="0"/>
               <a:buChar char="•"/>
               <a:spcAft>
-                <a:spcPts val="200"/>
+                <a:spcPts val="600"/>
               </a:spcAft>
             </a:pPr>
             <a:r>
-              <a:rPr sz="1400" b="0" i="0" u="none">
+              <a:rPr sz="1600" b="0" i="0" u="none">
                 <a:solidFill>
                   <a:srgbClr val="1A1A1A"/>
                 </a:solidFill>
                 <a:latin typeface="Arial"/>
                 <a:cs typeface="Arial" pitchFamily="34" charset="0"/>
               </a:rPr>
-              <a:t>A student submits their lab program. The platform runs it, marks it, and shows them exactly why they got each mark.</a:t>
-            </a:r>
-          </a:p>
-          <a:p>
-            <a:pPr algn="just" marL="329184" indent="-219456">
+              <a:t>A student submits their lab program. It is run, marked, and every mark is explained.</a:t>
+            </a:r>
+          </a:p>
+          <a:p>
+            <a:pPr algn="l" marL="329184" indent="-219456">
               <a:lnSpc>
-                <a:spcPct val="95000"/>
+                <a:spcPct val="112000"/>
               </a:lnSpc>
               <a:buFont typeface="Arial" pitchFamily="34" charset="0"/>
               <a:buChar char="•"/>
               <a:spcAft>
-                <a:spcPts val="200"/>
+                <a:spcPts val="600"/>
               </a:spcAft>
             </a:pPr>
             <a:r>
-              <a:rPr sz="1400" b="0" i="0" u="none">
+              <a:rPr sz="1600" b="0" i="0" u="none">
                 <a:solidFill>
                   <a:srgbClr val="1A1A1A"/>
                 </a:solidFill>
                 <a:latin typeface="Arial"/>
                 <a:cs typeface="Arial" pitchFamily="34" charset="0"/>
               </a:rPr>
-              <a:t>It does not stop at a number. Each mark is linked to a topic - loops, recursion, error handling - so the student sees which topic they are weak on, not just which lab.</a:t>
-            </a:r>
-          </a:p>
-          <a:p>
-            <a:pPr algn="just" marL="329184" indent="-219456">
+              <a:t>Each mark is tied to a topic, so a student sees which topic is weak - not just which lab.</a:t>
+            </a:r>
+          </a:p>
+          <a:p>
+            <a:pPr algn="l" marL="329184" indent="-219456">
               <a:lnSpc>
-                <a:spcPct val="95000"/>
+                <a:spcPct val="112000"/>
               </a:lnSpc>
               <a:buFont typeface="Arial" pitchFamily="34" charset="0"/>
               <a:buChar char="•"/>
               <a:spcAft>
-                <a:spcPts val="200"/>
+                <a:spcPts val="600"/>
               </a:spcAft>
             </a:pPr>
             <a:r>
-              <a:rPr sz="1400" b="0" i="0" u="none">
+              <a:rPr sz="1600" b="0" i="0" u="none">
                 <a:solidFill>
                   <a:srgbClr val="1A1A1A"/>
                 </a:solidFill>
                 <a:latin typeface="Arial"/>
                 <a:cs typeface="Arial" pitchFamily="34" charset="0"/>
               </a:rPr>
-              <a:t>Marks from every lab add up over the semester into a clear picture of what each student actually understands.</a:t>
+              <a:t>Those marks add up across the semester into a picture of what each student understands.</a:t>
             </a:r>
           </a:p>
           <a:p>
@@ -6145,14 +6145,14 @@
               <a:buFont typeface="Wingdings" pitchFamily="34" charset="0"/>
               <a:buChar char="v"/>
               <a:spcBef>
-                <a:spcPts val="700"/>
+                <a:spcPts val="2000"/>
               </a:spcBef>
               <a:spcAft>
-                <a:spcPts val="300"/>
+                <a:spcPts val="600"/>
               </a:spcAft>
             </a:pPr>
             <a:r>
-              <a:rPr sz="1700" b="1" i="0" u="sng">
+              <a:rPr sz="1800" b="1" i="0" u="sng">
                 <a:solidFill>
                   <a:srgbClr val="1F497D"/>
                 </a:solidFill>
@@ -6163,91 +6163,69 @@
             </a:r>
           </a:p>
           <a:p>
-            <a:pPr algn="just" marL="329184" indent="-219456">
+            <a:pPr algn="l" marL="329184" indent="-219456">
               <a:lnSpc>
-                <a:spcPct val="95000"/>
+                <a:spcPct val="112000"/>
               </a:lnSpc>
               <a:buFont typeface="Arial" pitchFamily="34" charset="0"/>
               <a:buChar char="•"/>
               <a:spcAft>
-                <a:spcPts val="200"/>
+                <a:spcPts val="600"/>
               </a:spcAft>
             </a:pPr>
             <a:r>
-              <a:rPr sz="1400" b="0" i="0" u="none">
+              <a:rPr sz="1600" b="0" i="0" u="none">
                 <a:solidFill>
                   <a:srgbClr val="1A1A1A"/>
                 </a:solidFill>
                 <a:latin typeface="Arial"/>
                 <a:cs typeface="Arial" pitchFamily="34" charset="0"/>
               </a:rPr>
-              <a:t>Collects the academic information: labs, submissions and class lists, straight from the college's existing Moodle or Google Classroom.</a:t>
-            </a:r>
-          </a:p>
-          <a:p>
-            <a:pPr algn="just" marL="329184" indent="-219456">
+              <a:t>Collects labs, submissions and class lists from the college's existing system.</a:t>
+            </a:r>
+          </a:p>
+          <a:p>
+            <a:pPr algn="l" marL="329184" indent="-219456">
               <a:lnSpc>
-                <a:spcPct val="95000"/>
+                <a:spcPct val="112000"/>
               </a:lnSpc>
               <a:buFont typeface="Arial" pitchFamily="34" charset="0"/>
               <a:buChar char="•"/>
               <a:spcAft>
-                <a:spcPts val="200"/>
+                <a:spcPts val="600"/>
               </a:spcAft>
             </a:pPr>
             <a:r>
-              <a:rPr sz="1400" b="0" i="0" u="none">
+              <a:rPr sz="1600" b="0" i="0" u="none">
                 <a:solidFill>
                   <a:srgbClr val="1A1A1A"/>
                 </a:solidFill>
                 <a:latin typeface="Arial"/>
                 <a:cs typeface="Arial" pitchFamily="34" charset="0"/>
               </a:rPr>
-              <a:t>Analyses it four ways: each submission, each student over time, each question, and the class as a whole.</a:t>
-            </a:r>
-          </a:p>
-          <a:p>
-            <a:pPr algn="just" marL="329184" indent="-219456">
+              <a:t>Analyses each submission, each student, each question and the whole class.</a:t>
+            </a:r>
+          </a:p>
+          <a:p>
+            <a:pPr algn="l" marL="329184" indent="-219456">
               <a:lnSpc>
-                <a:spcPct val="95000"/>
+                <a:spcPct val="112000"/>
               </a:lnSpc>
               <a:buFont typeface="Arial" pitchFamily="34" charset="0"/>
               <a:buChar char="•"/>
               <a:spcAft>
-                <a:spcPts val="200"/>
+                <a:spcPts val="600"/>
               </a:spcAft>
             </a:pPr>
             <a:r>
-              <a:rPr sz="1400" b="0" i="0" u="none">
+              <a:rPr sz="1600" b="0" i="0" u="none">
                 <a:solidFill>
                   <a:srgbClr val="1A1A1A"/>
                 </a:solidFill>
                 <a:latin typeface="Arial"/>
                 <a:cs typeface="Arial" pitchFamily="34" charset="0"/>
               </a:rPr>
-              <a:t>Gives everyone a next step: what a student should revise, what a teacher should explain again, which students need support.</a:t>
-            </a:r>
-          </a:p>
-          <a:p>
-            <a:pPr algn="just" marL="329184" indent="-219456">
-              <a:lnSpc>
-                <a:spcPct val="95000"/>
-              </a:lnSpc>
-              <a:buFont typeface="Arial" pitchFamily="34" charset="0"/>
-              <a:buChar char="•"/>
-              <a:spcAft>
-                <a:spcPts val="200"/>
-              </a:spcAft>
-            </a:pPr>
-            <a:r>
-              <a:rPr sz="1400" b="0" i="0" u="none">
-                <a:solidFill>
-                  <a:srgbClr val="1A1A1A"/>
-                </a:solidFill>
-                <a:latin typeface="Arial"/>
-                <a:cs typeface="Arial" pitchFamily="34" charset="0"/>
-              </a:rPr>
-              <a:t>Shows it on one simple screen per person - one for students, one for teachers, one for the department.</a:t>
+              <a:t>Tells students what to revise, and teachers what to explain again.</a:t>
             </a:r>
           </a:p>
           <a:p>
@@ -6258,14 +6236,14 @@
               <a:buFont typeface="Wingdings" pitchFamily="34" charset="0"/>
               <a:buChar char="v"/>
               <a:spcBef>
-                <a:spcPts val="700"/>
+                <a:spcPts val="2000"/>
               </a:spcBef>
               <a:spcAft>
-                <a:spcPts val="300"/>
+                <a:spcPts val="600"/>
               </a:spcAft>
             </a:pPr>
             <a:r>
-              <a:rPr sz="1700" b="1" i="0" u="sng">
+              <a:rPr sz="1800" b="1" i="0" u="sng">
                 <a:solidFill>
                   <a:srgbClr val="1F497D"/>
                 </a:solidFill>
@@ -6276,91 +6254,91 @@
             </a:r>
           </a:p>
           <a:p>
-            <a:pPr algn="just" marL="329184" indent="-219456">
+            <a:pPr algn="l" marL="329184" indent="-219456">
               <a:lnSpc>
-                <a:spcPct val="95000"/>
+                <a:spcPct val="112000"/>
               </a:lnSpc>
               <a:buFont typeface="Arial" pitchFamily="34" charset="0"/>
               <a:buChar char="•"/>
               <a:spcAft>
-                <a:spcPts val="200"/>
+                <a:spcPts val="600"/>
               </a:spcAft>
             </a:pPr>
             <a:r>
-              <a:rPr sz="1400" b="0" i="0" u="none">
+              <a:rPr sz="1600" b="0" i="0" u="none">
                 <a:solidFill>
                   <a:srgbClr val="1A1A1A"/>
                 </a:solidFill>
                 <a:latin typeface="Arial"/>
                 <a:cs typeface="Arial" pitchFamily="34" charset="0"/>
               </a:rPr>
-              <a:t>A missing bracket costs two marks, not the whole lab. We find the smallest fix that makes the program run, then mark the rest of the work properly.</a:t>
-            </a:r>
-          </a:p>
-          <a:p>
-            <a:pPr algn="just" marL="329184" indent="-219456">
+              <a:t>A missing bracket costs two marks, not the whole lab.</a:t>
+            </a:r>
+          </a:p>
+          <a:p>
+            <a:pPr algn="l" marL="329184" indent="-219456">
               <a:lnSpc>
-                <a:spcPct val="95000"/>
+                <a:spcPct val="112000"/>
               </a:lnSpc>
               <a:buFont typeface="Arial" pitchFamily="34" charset="0"/>
               <a:buChar char="•"/>
               <a:spcAft>
-                <a:spcPts val="200"/>
+                <a:spcPts val="600"/>
               </a:spcAft>
             </a:pPr>
             <a:r>
-              <a:rPr sz="1400" b="0" i="0" u="none">
+              <a:rPr sz="1600" b="0" i="0" u="none">
                 <a:solidFill>
                   <a:srgbClr val="1A1A1A"/>
                 </a:solidFill>
                 <a:latin typeface="Arial"/>
                 <a:cs typeface="Arial" pitchFamily="34" charset="0"/>
               </a:rPr>
-              <a:t>The answer key never goes near the student's program, so it cannot be copied, guessed or hard-coded.</a:t>
-            </a:r>
-          </a:p>
-          <a:p>
-            <a:pPr algn="just" marL="329184" indent="-219456">
+              <a:t>The answer key never touches the student's program, so it cannot be copied.</a:t>
+            </a:r>
+          </a:p>
+          <a:p>
+            <a:pPr algn="l" marL="329184" indent="-219456">
               <a:lnSpc>
-                <a:spcPct val="95000"/>
+                <a:spcPct val="112000"/>
               </a:lnSpc>
               <a:buFont typeface="Arial" pitchFamily="34" charset="0"/>
               <a:buChar char="•"/>
               <a:spcAft>
-                <a:spcPts val="200"/>
+                <a:spcPts val="600"/>
               </a:spcAft>
             </a:pPr>
             <a:r>
-              <a:rPr sz="1400" b="0" i="0" u="none">
+              <a:rPr sz="1600" b="0" i="0" u="none">
                 <a:solidFill>
                   <a:srgbClr val="1A1A1A"/>
                 </a:solidFill>
                 <a:latin typeface="Arial"/>
                 <a:cs typeface="Arial" pitchFamily="34" charset="0"/>
               </a:rPr>
-              <a:t>It also marks the question paper. If the strongest students all fail one part, the question was probably unclear, and the teacher is told.</a:t>
-            </a:r>
-          </a:p>
-          <a:p>
-            <a:pPr algn="just" marL="329184" indent="-219456">
+              <a:t>It marks the question paper too - unclear questions are flagged to the teacher.</a:t>
+            </a:r>
+          </a:p>
+          <a:p>
+            <a:pPr algn="l" marL="329184" indent="-219456">
               <a:lnSpc>
-                <a:spcPct val="95000"/>
+                <a:spcPct val="112000"/>
               </a:lnSpc>
               <a:buFont typeface="Arial" pitchFamily="34" charset="0"/>
               <a:buChar char="•"/>
               <a:spcAft>
-                <a:spcPts val="200"/>
+                <a:spcPts val="600"/>
               </a:spcAft>
             </a:pPr>
             <a:r>
-              <a:rPr sz="1400" b="0" i="0" u="none">
+              <a:rPr sz="1600" b="0" i="0" u="none">
                 <a:solidFill>
                   <a:srgbClr val="1A1A1A"/>
                 </a:solidFill>
                 <a:latin typeface="Arial"/>
                 <a:cs typeface="Arial" pitchFamily="34" charset="0"/>
               </a:rPr>
-              <a:t>When it is not sure, it says so and hands the submission to the teacher instead of guessing.</a:t>
+              <a:t>When it is unsure, it says so and hands the work to a human.</a:t>
             </a:r>
           </a:p>
         </p:txBody>
@@ -6644,7 +6622,7 @@
         <p:spPr bwMode="auto">
           <a:xfrm>
             <a:off x="329184" y="3310128"/>
-            <a:ext cx="11503152" cy="2926080"/>
+            <a:ext cx="11503152" cy="2907792"/>
           </a:xfrm>
           <a:prstGeom prst="rect">
             <a:avLst/>
@@ -6668,11 +6646,11 @@
               <a:buFont typeface="Wingdings" pitchFamily="34" charset="0"/>
               <a:buChar char="v"/>
               <a:spcAft>
-                <a:spcPts val="500"/>
+                <a:spcPts val="600"/>
               </a:spcAft>
             </a:pPr>
             <a:r>
-              <a:rPr sz="1600" b="1" i="0" u="sng">
+              <a:rPr sz="1500" b="1" i="0" u="sng">
                 <a:solidFill>
                   <a:srgbClr val="1F497D"/>
                 </a:solidFill>
@@ -6683,14 +6661,14 @@
             </a:r>
           </a:p>
           <a:p>
-            <a:pPr algn="just" marL="329184" indent="-219456">
+            <a:pPr algn="l" marL="329184" indent="-219456">
               <a:lnSpc>
-                <a:spcPct val="95000"/>
+                <a:spcPct val="106000"/>
               </a:lnSpc>
               <a:buFont typeface="Arial" pitchFamily="34" charset="0"/>
               <a:buChar char="•"/>
               <a:spcAft>
-                <a:spcPts val="300"/>
+                <a:spcPts val="400"/>
               </a:spcAft>
             </a:pPr>
             <a:r>
@@ -6701,18 +6679,18 @@
                 <a:latin typeface="Arial"/>
                 <a:cs typeface="Arial" pitchFamily="34" charset="0"/>
               </a:rPr>
-              <a:t>Python and FastAPI on the server. A plain web interface that works in any browser, with nothing to install on a student's machine.</a:t>
-            </a:r>
-          </a:p>
-          <a:p>
-            <a:pPr algn="just" marL="329184" indent="-219456">
+              <a:t>Python and FastAPI, with a plain web interface that runs in any browser.</a:t>
+            </a:r>
+          </a:p>
+          <a:p>
+            <a:pPr algn="l" marL="329184" indent="-219456">
               <a:lnSpc>
-                <a:spcPct val="95000"/>
+                <a:spcPct val="106000"/>
               </a:lnSpc>
               <a:buFont typeface="Arial" pitchFamily="34" charset="0"/>
               <a:buChar char="•"/>
               <a:spcAft>
-                <a:spcPts val="300"/>
+                <a:spcPts val="400"/>
               </a:spcAft>
             </a:pPr>
             <a:r>
@@ -6723,18 +6701,18 @@
                 <a:latin typeface="Arial"/>
                 <a:cs typeface="Arial" pitchFamily="34" charset="0"/>
               </a:rPr>
-              <a:t>Student programs run inside a locked-down sandbox, so nothing they submit can touch the college's systems or see anyone else's work.</a:t>
-            </a:r>
-          </a:p>
-          <a:p>
-            <a:pPr algn="just" marL="329184" indent="-219456">
+              <a:t>Student programs run inside a sealed sandbox, away from college systems.</a:t>
+            </a:r>
+          </a:p>
+          <a:p>
+            <a:pPr algn="l" marL="329184" indent="-219456">
               <a:lnSpc>
-                <a:spcPct val="95000"/>
+                <a:spcPct val="106000"/>
               </a:lnSpc>
               <a:buFont typeface="Arial" pitchFamily="34" charset="0"/>
               <a:buChar char="•"/>
               <a:spcAft>
-                <a:spcPts val="300"/>
+                <a:spcPts val="400"/>
               </a:spcAft>
             </a:pPr>
             <a:r>
@@ -6745,18 +6723,18 @@
                 <a:latin typeface="Arial"/>
                 <a:cs typeface="Arial" pitchFamily="34" charset="0"/>
               </a:rPr>
-              <a:t>Well-established methods do the marking: standard program analysis, the same plagiarism technique universities already use, and a well-known model for tracking what a learner knows.</a:t>
-            </a:r>
-          </a:p>
-          <a:p>
-            <a:pPr algn="just" marL="329184" indent="-219456">
+              <a:t>Proven methods for marking, plagiarism checking and tracking what a learner knows.</a:t>
+            </a:r>
+          </a:p>
+          <a:p>
+            <a:pPr algn="l" marL="329184" indent="-219456">
               <a:lnSpc>
-                <a:spcPct val="95000"/>
+                <a:spcPct val="106000"/>
               </a:lnSpc>
               <a:buFont typeface="Arial" pitchFamily="34" charset="0"/>
               <a:buChar char="•"/>
               <a:spcAft>
-                <a:spcPts val="300"/>
+                <a:spcPts val="400"/>
               </a:spcAft>
             </a:pPr>
             <a:r>
@@ -6767,7 +6745,7 @@
                 <a:latin typeface="Arial"/>
                 <a:cs typeface="Arial" pitchFamily="34" charset="0"/>
               </a:rPr>
-              <a:t>Runs on an ordinary computer. No expensive hardware, no paid AI service needed to mark a submission.</a:t>
+              <a:t>Ordinary hardware - no GPU, and no paid AI service to mark a submission.</a:t>
             </a:r>
           </a:p>
           <a:p>
@@ -6778,14 +6756,14 @@
               <a:buFont typeface="Wingdings" pitchFamily="34" charset="0"/>
               <a:buChar char="v"/>
               <a:spcBef>
-                <a:spcPts val="1000"/>
+                <a:spcPts val="1100"/>
               </a:spcBef>
               <a:spcAft>
-                <a:spcPts val="500"/>
+                <a:spcPts val="600"/>
               </a:spcAft>
             </a:pPr>
             <a:r>
-              <a:rPr sz="1600" b="1" i="0" u="sng">
+              <a:rPr sz="1500" b="1" i="0" u="sng">
                 <a:solidFill>
                   <a:srgbClr val="1F497D"/>
                 </a:solidFill>
@@ -6796,14 +6774,14 @@
             </a:r>
           </a:p>
           <a:p>
-            <a:pPr algn="just" marL="329184" indent="-219456">
+            <a:pPr algn="l" marL="329184" indent="-219456">
               <a:lnSpc>
-                <a:spcPct val="95000"/>
+                <a:spcPct val="106000"/>
               </a:lnSpc>
               <a:buFont typeface="Arial" pitchFamily="34" charset="0"/>
               <a:buChar char="•"/>
               <a:spcAft>
-                <a:spcPts val="300"/>
+                <a:spcPts val="400"/>
               </a:spcAft>
             </a:pPr>
             <a:r>
@@ -6814,18 +6792,18 @@
                 <a:latin typeface="Arial"/>
                 <a:cs typeface="Arial" pitchFamily="34" charset="0"/>
               </a:rPr>
-              <a:t>The teacher writes the lab question in ordinary English. The platform reads it and works out what it can check - and shows the teacher that list before anything is published.</a:t>
-            </a:r>
-          </a:p>
-          <a:p>
-            <a:pPr algn="just" marL="329184" indent="-219456">
+              <a:t>The teacher writes the question in plain English; the platform shows what it will check before anything is published.</a:t>
+            </a:r>
+          </a:p>
+          <a:p>
+            <a:pPr algn="l" marL="329184" indent="-219456">
               <a:lnSpc>
-                <a:spcPct val="95000"/>
+                <a:spcPct val="106000"/>
               </a:lnSpc>
               <a:buFont typeface="Arial" pitchFamily="34" charset="0"/>
               <a:buChar char="•"/>
               <a:spcAft>
-                <a:spcPts val="300"/>
+                <a:spcPts val="400"/>
               </a:spcAft>
             </a:pPr>
             <a:r>
@@ -6836,7 +6814,7 @@
                 <a:latin typeface="Arial"/>
                 <a:cs typeface="Arial" pitchFamily="34" charset="0"/>
               </a:rPr>
-              <a:t>Working prototype today: a full class of 24 students across four labs, marked from start to finish, with every screen above already built.</a:t>
+              <a:t>Working prototype: a class of 24 students across four labs, marked end to end.</a:t>
             </a:r>
           </a:p>
         </p:txBody>
@@ -7037,15 +7015,15 @@
           <a:p>
             <a:pPr algn="ctr" marL="0" indent="0">
               <a:lnSpc>
-                <a:spcPct val="95000"/>
+                <a:spcPct val="100000"/>
               </a:lnSpc>
               <a:buNone/>
               <a:spcAft>
-                <a:spcPts val="300"/>
+                <a:spcPts val="400"/>
               </a:spcAft>
             </a:pPr>
             <a:r>
-              <a:rPr sz="1050" b="1" i="0" u="none">
+              <a:rPr sz="1100" b="1" i="0" u="none">
                 <a:solidFill>
                   <a:srgbClr val="FFFFFF"/>
                 </a:solidFill>
@@ -7058,12 +7036,12 @@
           <a:p>
             <a:pPr algn="ctr" marL="0" indent="0">
               <a:lnSpc>
-                <a:spcPct val="90000"/>
+                <a:spcPct val="106000"/>
               </a:lnSpc>
               <a:buNone/>
             </a:pPr>
             <a:r>
-              <a:rPr sz="850" b="0" i="0" u="none">
+              <a:rPr sz="950" b="0" i="0" u="none">
                 <a:solidFill>
                   <a:srgbClr val="FFFFFF"/>
                 </a:solidFill>
@@ -7157,15 +7135,15 @@
           <a:p>
             <a:pPr algn="ctr" marL="0" indent="0">
               <a:lnSpc>
-                <a:spcPct val="95000"/>
+                <a:spcPct val="100000"/>
               </a:lnSpc>
               <a:buNone/>
               <a:spcAft>
-                <a:spcPts val="300"/>
+                <a:spcPts val="400"/>
               </a:spcAft>
             </a:pPr>
             <a:r>
-              <a:rPr sz="1050" b="1" i="0" u="none">
+              <a:rPr sz="1100" b="1" i="0" u="none">
                 <a:solidFill>
                   <a:srgbClr val="FFFFFF"/>
                 </a:solidFill>
@@ -7178,12 +7156,12 @@
           <a:p>
             <a:pPr algn="ctr" marL="0" indent="0">
               <a:lnSpc>
-                <a:spcPct val="90000"/>
+                <a:spcPct val="106000"/>
               </a:lnSpc>
               <a:buNone/>
             </a:pPr>
             <a:r>
-              <a:rPr sz="850" b="0" i="0" u="none">
+              <a:rPr sz="950" b="0" i="0" u="none">
                 <a:solidFill>
                   <a:srgbClr val="FFFFFF"/>
                 </a:solidFill>
@@ -7277,15 +7255,15 @@
           <a:p>
             <a:pPr algn="ctr" marL="0" indent="0">
               <a:lnSpc>
-                <a:spcPct val="95000"/>
+                <a:spcPct val="100000"/>
               </a:lnSpc>
               <a:buNone/>
               <a:spcAft>
-                <a:spcPts val="300"/>
+                <a:spcPts val="400"/>
               </a:spcAft>
             </a:pPr>
             <a:r>
-              <a:rPr sz="1050" b="1" i="0" u="none">
+              <a:rPr sz="1100" b="1" i="0" u="none">
                 <a:solidFill>
                   <a:srgbClr val="FFFFFF"/>
                 </a:solidFill>
@@ -7298,12 +7276,12 @@
           <a:p>
             <a:pPr algn="ctr" marL="0" indent="0">
               <a:lnSpc>
-                <a:spcPct val="90000"/>
+                <a:spcPct val="106000"/>
               </a:lnSpc>
               <a:buNone/>
             </a:pPr>
             <a:r>
-              <a:rPr sz="850" b="0" i="0" u="none">
+              <a:rPr sz="950" b="0" i="0" u="none">
                 <a:solidFill>
                   <a:srgbClr val="FFFFFF"/>
                 </a:solidFill>
@@ -7397,15 +7375,15 @@
           <a:p>
             <a:pPr algn="ctr" marL="0" indent="0">
               <a:lnSpc>
-                <a:spcPct val="95000"/>
+                <a:spcPct val="100000"/>
               </a:lnSpc>
               <a:buNone/>
               <a:spcAft>
-                <a:spcPts val="300"/>
+                <a:spcPts val="400"/>
               </a:spcAft>
             </a:pPr>
             <a:r>
-              <a:rPr sz="1050" b="1" i="0" u="none">
+              <a:rPr sz="1100" b="1" i="0" u="none">
                 <a:solidFill>
                   <a:srgbClr val="FFFFFF"/>
                 </a:solidFill>
@@ -7418,12 +7396,12 @@
           <a:p>
             <a:pPr algn="ctr" marL="0" indent="0">
               <a:lnSpc>
-                <a:spcPct val="90000"/>
+                <a:spcPct val="106000"/>
               </a:lnSpc>
               <a:buNone/>
             </a:pPr>
             <a:r>
-              <a:rPr sz="850" b="0" i="0" u="none">
+              <a:rPr sz="950" b="0" i="0" u="none">
                 <a:solidFill>
                   <a:srgbClr val="FFFFFF"/>
                 </a:solidFill>
@@ -7459,12 +7437,12 @@
           <a:p>
             <a:pPr algn="ctr" marL="0" indent="0">
               <a:lnSpc>
-                <a:spcPct val="95000"/>
+                <a:spcPct val="104000"/>
               </a:lnSpc>
               <a:buNone/>
             </a:pPr>
             <a:r>
-              <a:rPr sz="1100" b="1" i="0" u="none">
+              <a:rPr sz="1150" b="1" i="0" u="none">
                 <a:solidFill>
                   <a:srgbClr val="1F497D"/>
                 </a:solidFill>
@@ -7617,8 +7595,8 @@
         </p:nvSpPr>
         <p:spPr bwMode="auto">
           <a:xfrm>
-            <a:off x="329184" y="1152144"/>
-            <a:ext cx="11503152" cy="4261104"/>
+            <a:off x="329184" y="1188720"/>
+            <a:ext cx="11503152" cy="4206240"/>
           </a:xfrm>
           <a:prstGeom prst="rect">
             <a:avLst/>
@@ -7675,14 +7653,14 @@
               <a:buFont typeface="Wingdings" pitchFamily="34" charset="0"/>
               <a:buChar char="v"/>
               <a:spcBef>
-                <a:spcPts val="700"/>
+                <a:spcPts val="1300"/>
               </a:spcBef>
               <a:spcAft>
-                <a:spcPts val="300"/>
+                <a:spcPts val="600"/>
               </a:spcAft>
             </a:pPr>
             <a:r>
-              <a:rPr sz="1700" b="1" i="0" u="sng">
+              <a:rPr sz="1600" b="1" i="0" u="sng">
                 <a:solidFill>
                   <a:srgbClr val="1F497D"/>
                 </a:solidFill>
@@ -7693,18 +7671,18 @@
             </a:r>
           </a:p>
           <a:p>
-            <a:pPr algn="just" marL="329184" indent="-219456">
+            <a:pPr algn="l" marL="329184" indent="-219456">
               <a:lnSpc>
-                <a:spcPct val="95000"/>
+                <a:spcPct val="106000"/>
               </a:lnSpc>
               <a:buFont typeface="Arial" pitchFamily="34" charset="0"/>
               <a:buChar char="•"/>
               <a:spcAft>
-                <a:spcPts val="200"/>
+                <a:spcPts val="400"/>
               </a:spcAft>
             </a:pPr>
             <a:r>
-              <a:rPr sz="1400" b="0" i="0" u="none">
+              <a:rPr sz="1350" b="0" i="0" u="none">
                 <a:solidFill>
                   <a:srgbClr val="1A1A1A"/>
                 </a:solidFill>
@@ -7715,47 +7693,47 @@
             </a:r>
           </a:p>
           <a:p>
-            <a:pPr algn="just" marL="329184" indent="-219456">
+            <a:pPr algn="l" marL="329184" indent="-219456">
               <a:lnSpc>
-                <a:spcPct val="95000"/>
+                <a:spcPct val="106000"/>
               </a:lnSpc>
               <a:buFont typeface="Arial" pitchFamily="34" charset="0"/>
               <a:buChar char="•"/>
               <a:spcAft>
-                <a:spcPts val="200"/>
+                <a:spcPts val="400"/>
               </a:spcAft>
             </a:pPr>
             <a:r>
-              <a:rPr sz="1400" b="0" i="0" u="none">
+              <a:rPr sz="1350" b="0" i="0" u="none">
                 <a:solidFill>
                   <a:srgbClr val="1A1A1A"/>
                 </a:solidFill>
                 <a:latin typeface="Arial"/>
                 <a:cs typeface="Arial" pitchFamily="34" charset="0"/>
               </a:rPr>
-              <a:t>It runs on a normal laptop or a small college server, and setting up one lab takes a teacher about ten minutes.</a:t>
-            </a:r>
-          </a:p>
-          <a:p>
-            <a:pPr algn="just" marL="329184" indent="-219456">
+              <a:t>Runs on a normal laptop or a small college server.</a:t>
+            </a:r>
+          </a:p>
+          <a:p>
+            <a:pPr algn="l" marL="329184" indent="-219456">
               <a:lnSpc>
-                <a:spcPct val="95000"/>
+                <a:spcPct val="106000"/>
               </a:lnSpc>
               <a:buFont typeface="Arial" pitchFamily="34" charset="0"/>
               <a:buChar char="•"/>
               <a:spcAft>
-                <a:spcPts val="200"/>
+                <a:spcPts val="400"/>
               </a:spcAft>
             </a:pPr>
             <a:r>
-              <a:rPr sz="1400" b="0" i="0" u="none">
+              <a:rPr sz="1350" b="0" i="0" u="none">
                 <a:solidFill>
                   <a:srgbClr val="1A1A1A"/>
                 </a:solidFill>
                 <a:latin typeface="Arial"/>
                 <a:cs typeface="Arial" pitchFamily="34" charset="0"/>
               </a:rPr>
-              <a:t>It fits into the tools a college already uses, so marks go back into the existing gradebook automatically.</a:t>
+              <a:t>Fits the tools a college already uses, so marks return to the existing gradebook.</a:t>
             </a:r>
           </a:p>
           <a:p>
@@ -7766,14 +7744,14 @@
               <a:buFont typeface="Wingdings" pitchFamily="34" charset="0"/>
               <a:buChar char="v"/>
               <a:spcBef>
-                <a:spcPts val="700"/>
+                <a:spcPts val="1300"/>
               </a:spcBef>
               <a:spcAft>
-                <a:spcPts val="300"/>
+                <a:spcPts val="600"/>
               </a:spcAft>
             </a:pPr>
             <a:r>
-              <a:rPr sz="1700" b="1" i="0" u="sng">
+              <a:rPr sz="1600" b="1" i="0" u="sng">
                 <a:solidFill>
                   <a:srgbClr val="1F497D"/>
                 </a:solidFill>
@@ -7784,91 +7762,91 @@
             </a:r>
           </a:p>
           <a:p>
-            <a:pPr algn="just" marL="329184" indent="-219456">
+            <a:pPr algn="l" marL="329184" indent="-219456">
               <a:lnSpc>
-                <a:spcPct val="95000"/>
+                <a:spcPct val="106000"/>
               </a:lnSpc>
               <a:buFont typeface="Arial" pitchFamily="34" charset="0"/>
               <a:buChar char="•"/>
               <a:spcAft>
-                <a:spcPts val="200"/>
+                <a:spcPts val="400"/>
               </a:spcAft>
             </a:pPr>
             <a:r>
-              <a:rPr sz="1400" b="0" i="0" u="none">
+              <a:rPr sz="1350" b="0" i="0" u="none">
                 <a:solidFill>
                   <a:srgbClr val="1A1A1A"/>
                 </a:solidFill>
                 <a:latin typeface="Arial"/>
                 <a:cs typeface="Arial" pitchFamily="34" charset="0"/>
               </a:rPr>
-              <a:t>Student programs are run on our machine, and some of them will be badly behaved.</a:t>
-            </a:r>
-          </a:p>
-          <a:p>
-            <a:pPr algn="just" marL="329184" indent="-219456">
+              <a:t>Running students' programs safely on our own machine.</a:t>
+            </a:r>
+          </a:p>
+          <a:p>
+            <a:pPr algn="l" marL="329184" indent="-219456">
               <a:lnSpc>
-                <a:spcPct val="95000"/>
+                <a:spcPct val="106000"/>
               </a:lnSpc>
               <a:buFont typeface="Arial" pitchFamily="34" charset="0"/>
               <a:buChar char="•"/>
               <a:spcAft>
-                <a:spcPts val="200"/>
+                <a:spcPts val="400"/>
               </a:spcAft>
             </a:pPr>
             <a:r>
-              <a:rPr sz="1400" b="0" i="0" u="none">
+              <a:rPr sz="1350" b="0" i="0" u="none">
                 <a:solidFill>
                   <a:srgbClr val="1A1A1A"/>
                 </a:solidFill>
                 <a:latin typeface="Arial"/>
                 <a:cs typeface="Arial" pitchFamily="34" charset="0"/>
               </a:rPr>
-              <a:t>Automatic marking can get things wrong, and a wrong mark destroys trust quickly.</a:t>
-            </a:r>
-          </a:p>
-          <a:p>
-            <a:pPr algn="just" marL="329184" indent="-219456">
+              <a:t>A wrong automatic mark loses a class's trust very quickly.</a:t>
+            </a:r>
+          </a:p>
+          <a:p>
+            <a:pPr algn="l" marL="329184" indent="-219456">
               <a:lnSpc>
-                <a:spcPct val="95000"/>
+                <a:spcPct val="106000"/>
               </a:lnSpc>
               <a:buFont typeface="Arial" pitchFamily="34" charset="0"/>
               <a:buChar char="•"/>
               <a:spcAft>
-                <a:spcPts val="200"/>
+                <a:spcPts val="400"/>
               </a:spcAft>
             </a:pPr>
             <a:r>
-              <a:rPr sz="1400" b="0" i="0" u="none">
+              <a:rPr sz="1350" b="0" i="0" u="none">
                 <a:solidFill>
                   <a:srgbClr val="1A1A1A"/>
                 </a:solidFill>
                 <a:latin typeface="Arial"/>
                 <a:cs typeface="Arial" pitchFamily="34" charset="0"/>
               </a:rPr>
-              <a:t>Wrongly accusing a student of copying is the most damaging mistake the system could make.</a:t>
-            </a:r>
-          </a:p>
-          <a:p>
-            <a:pPr algn="just" marL="329184" indent="-219456">
+              <a:t>Wrongly accusing a student of copying.</a:t>
+            </a:r>
+          </a:p>
+          <a:p>
+            <a:pPr algn="l" marL="329184" indent="-219456">
               <a:lnSpc>
-                <a:spcPct val="95000"/>
+                <a:spcPct val="106000"/>
               </a:lnSpc>
               <a:buFont typeface="Arial" pitchFamily="34" charset="0"/>
               <a:buChar char="•"/>
               <a:spcAft>
-                <a:spcPts val="200"/>
+                <a:spcPts val="400"/>
               </a:spcAft>
             </a:pPr>
             <a:r>
-              <a:rPr sz="1400" b="0" i="0" u="none">
+              <a:rPr sz="1350" b="0" i="0" u="none">
                 <a:solidFill>
                   <a:srgbClr val="1A1A1A"/>
                 </a:solidFill>
                 <a:latin typeface="Arial"/>
                 <a:cs typeface="Arial" pitchFamily="34" charset="0"/>
               </a:rPr>
-              <a:t>Teachers will abandon anything that costs them more time than it saves.</a:t>
+              <a:t>Teachers abandoning anything that costs more time than it saves.</a:t>
             </a:r>
           </a:p>
           <a:p>
@@ -7879,14 +7857,14 @@
               <a:buFont typeface="Wingdings" pitchFamily="34" charset="0"/>
               <a:buChar char="v"/>
               <a:spcBef>
-                <a:spcPts val="700"/>
+                <a:spcPts val="1300"/>
               </a:spcBef>
               <a:spcAft>
-                <a:spcPts val="300"/>
+                <a:spcPts val="600"/>
               </a:spcAft>
             </a:pPr>
             <a:r>
-              <a:rPr sz="1700" b="1" i="0" u="sng">
+              <a:rPr sz="1600" b="1" i="0" u="sng">
                 <a:solidFill>
                   <a:srgbClr val="1F497D"/>
                 </a:solidFill>
@@ -7897,91 +7875,91 @@
             </a:r>
           </a:p>
           <a:p>
-            <a:pPr algn="just" marL="329184" indent="-219456">
+            <a:pPr algn="l" marL="329184" indent="-219456">
               <a:lnSpc>
-                <a:spcPct val="95000"/>
+                <a:spcPct val="106000"/>
               </a:lnSpc>
               <a:buFont typeface="Arial" pitchFamily="34" charset="0"/>
               <a:buChar char="•"/>
               <a:spcAft>
-                <a:spcPts val="200"/>
+                <a:spcPts val="400"/>
               </a:spcAft>
             </a:pPr>
             <a:r>
-              <a:rPr sz="1400" b="0" i="0" u="none">
+              <a:rPr sz="1350" b="0" i="0" u="none">
                 <a:solidFill>
                   <a:srgbClr val="1A1A1A"/>
                 </a:solidFill>
                 <a:latin typeface="Arial"/>
                 <a:cs typeface="Arial" pitchFamily="34" charset="0"/>
               </a:rPr>
-              <a:t>Every program runs sealed off from everything else, and is thrown away afterwards.</a:t>
-            </a:r>
-          </a:p>
-          <a:p>
-            <a:pPr algn="just" marL="329184" indent="-219456">
+              <a:t>Every program runs sealed off from everything else, then is destroyed.</a:t>
+            </a:r>
+          </a:p>
+          <a:p>
+            <a:pPr algn="l" marL="329184" indent="-219456">
               <a:lnSpc>
-                <a:spcPct val="95000"/>
+                <a:spcPct val="106000"/>
               </a:lnSpc>
               <a:buFont typeface="Arial" pitchFamily="34" charset="0"/>
               <a:buChar char="•"/>
               <a:spcAft>
-                <a:spcPts val="200"/>
+                <a:spcPts val="400"/>
               </a:spcAft>
             </a:pPr>
             <a:r>
-              <a:rPr sz="1400" b="0" i="0" u="none">
+              <a:rPr sz="1350" b="0" i="0" u="none">
                 <a:solidFill>
                   <a:srgbClr val="1A1A1A"/>
                 </a:solidFill>
                 <a:latin typeface="Arial"/>
                 <a:cs typeface="Arial" pitchFamily="34" charset="0"/>
               </a:rPr>
-              <a:t>The system knows when it is unsure and sends those submissions to the teacher. Students can question any mark and get a human answer.</a:t>
-            </a:r>
-          </a:p>
-          <a:p>
-            <a:pPr algn="just" marL="329184" indent="-219456">
+              <a:t>Unsure work goes to the teacher, and any student can question any mark.</a:t>
+            </a:r>
+          </a:p>
+          <a:p>
+            <a:pPr algn="l" marL="329184" indent="-219456">
               <a:lnSpc>
-                <a:spcPct val="95000"/>
+                <a:spcPct val="106000"/>
               </a:lnSpc>
               <a:buFont typeface="Arial" pitchFamily="34" charset="0"/>
               <a:buChar char="•"/>
               <a:spcAft>
-                <a:spcPts val="200"/>
+                <a:spcPts val="400"/>
               </a:spcAft>
             </a:pPr>
             <a:r>
-              <a:rPr sz="1400" b="0" i="0" u="none">
+              <a:rPr sz="1350" b="0" i="0" u="none">
                 <a:solidFill>
                   <a:srgbClr val="1A1A1A"/>
                 </a:solidFill>
                 <a:latin typeface="Arial"/>
                 <a:cs typeface="Arial" pitchFamily="34" charset="0"/>
               </a:rPr>
-              <a:t>For copying, it only shows the overlapping lines side by side. The judgement stays with the teacher - the platform never accuses anyone.</a:t>
-            </a:r>
-          </a:p>
-          <a:p>
-            <a:pPr algn="just" marL="329184" indent="-219456">
+              <a:t>For copying we show the matching lines only. The teacher decides.</a:t>
+            </a:r>
+          </a:p>
+          <a:p>
+            <a:pPr algn="l" marL="329184" indent="-219456">
               <a:lnSpc>
-                <a:spcPct val="95000"/>
+                <a:spcPct val="106000"/>
               </a:lnSpc>
               <a:buFont typeface="Arial" pitchFamily="34" charset="0"/>
               <a:buChar char="•"/>
               <a:spcAft>
-                <a:spcPts val="200"/>
+                <a:spcPts val="400"/>
               </a:spcAft>
             </a:pPr>
             <a:r>
-              <a:rPr sz="1400" b="0" i="0" u="none">
+              <a:rPr sz="1350" b="0" i="0" u="none">
                 <a:solidFill>
                   <a:srgbClr val="1A1A1A"/>
                 </a:solidFill>
                 <a:latin typeface="Arial"/>
                 <a:cs typeface="Arial" pitchFamily="34" charset="0"/>
               </a:rPr>
-              <a:t>Set-up is ten minutes, marks flow back into the existing gradebook, and every correction a teacher makes teaches the system to do better next time.</a:t>
+              <a:t>Ten-minute setup, and every correction a teacher makes trains the system.</a:t>
             </a:r>
           </a:p>
         </p:txBody>
@@ -8265,7 +8243,7 @@
           <a:p>
             <a:pPr algn="ctr" marL="0" indent="0">
               <a:lnSpc>
-                <a:spcPct val="90000"/>
+                <a:spcPct val="100000"/>
               </a:lnSpc>
               <a:buNone/>
             </a:pPr>
@@ -8283,7 +8261,7 @@
           <a:p>
             <a:pPr algn="ctr" marL="0" indent="0">
               <a:lnSpc>
-                <a:spcPct val="88000"/>
+                <a:spcPct val="104000"/>
               </a:lnSpc>
               <a:buNone/>
             </a:pPr>
@@ -8295,7 +8273,7 @@
                 <a:latin typeface="Arial"/>
                 <a:cs typeface="Arial" pitchFamily="34" charset="0"/>
               </a:rPr>
-              <a:t>a full class of 24 students and four labs, marked end to end</a:t>
+              <a:t>a class of 24 students and four labs, marked end to end</a:t>
             </a:r>
           </a:p>
         </p:txBody>
@@ -8344,7 +8322,7 @@
           <a:p>
             <a:pPr algn="ctr" marL="0" indent="0">
               <a:lnSpc>
-                <a:spcPct val="90000"/>
+                <a:spcPct val="100000"/>
               </a:lnSpc>
               <a:buNone/>
             </a:pPr>
@@ -8362,7 +8340,7 @@
           <a:p>
             <a:pPr algn="ctr" marL="0" indent="0">
               <a:lnSpc>
-                <a:spcPct val="88000"/>
+                <a:spcPct val="104000"/>
               </a:lnSpc>
               <a:buNone/>
             </a:pPr>
@@ -8423,7 +8401,7 @@
           <a:p>
             <a:pPr algn="ctr" marL="0" indent="0">
               <a:lnSpc>
-                <a:spcPct val="90000"/>
+                <a:spcPct val="100000"/>
               </a:lnSpc>
               <a:buNone/>
             </a:pPr>
@@ -8441,7 +8419,7 @@
           <a:p>
             <a:pPr algn="ctr" marL="0" indent="0">
               <a:lnSpc>
-                <a:spcPct val="88000"/>
+                <a:spcPct val="104000"/>
               </a:lnSpc>
               <a:buNone/>
             </a:pPr>
@@ -8453,7 +8431,7 @@
                 <a:latin typeface="Arial"/>
                 <a:cs typeface="Arial" pitchFamily="34" charset="0"/>
               </a:rPr>
-              <a:t>runs on ordinary hardware, no paid AI service to mark work</a:t>
+              <a:t>ordinary hardware, no paid AI service</a:t>
             </a:r>
           </a:p>
         </p:txBody>
@@ -8604,8 +8582,8 @@
         </p:nvSpPr>
         <p:spPr bwMode="auto">
           <a:xfrm>
-            <a:off x="329184" y="1152144"/>
-            <a:ext cx="11503152" cy="5029200"/>
+            <a:off x="329184" y="1389888"/>
+            <a:ext cx="11503152" cy="4791456"/>
           </a:xfrm>
           <a:prstGeom prst="rect">
             <a:avLst/>
@@ -8648,14 +8626,14 @@
               <a:buFont typeface="Wingdings" pitchFamily="34" charset="0"/>
               <a:buChar char="v"/>
               <a:spcBef>
-                <a:spcPts val="700"/>
+                <a:spcPts val="3400"/>
               </a:spcBef>
               <a:spcAft>
-                <a:spcPts val="300"/>
+                <a:spcPts val="600"/>
               </a:spcAft>
             </a:pPr>
             <a:r>
-              <a:rPr sz="1700" b="1" i="0" u="sng">
+              <a:rPr sz="2000" b="1" i="0" u="sng">
                 <a:solidFill>
                   <a:srgbClr val="1F497D"/>
                 </a:solidFill>
@@ -8666,69 +8644,69 @@
             </a:r>
           </a:p>
           <a:p>
-            <a:pPr algn="just" marL="329184" indent="-219456">
+            <a:pPr algn="l" marL="329184" indent="-219456">
               <a:lnSpc>
-                <a:spcPct val="95000"/>
+                <a:spcPct val="118000"/>
               </a:lnSpc>
               <a:buFont typeface="Arial" pitchFamily="34" charset="0"/>
               <a:buChar char="•"/>
               <a:spcAft>
-                <a:spcPts val="200"/>
+                <a:spcPts val="1300"/>
               </a:spcAft>
             </a:pPr>
             <a:r>
-              <a:rPr sz="1500" b="0" i="0" u="none">
+              <a:rPr sz="1750" b="0" i="0" u="none">
                 <a:solidFill>
                   <a:srgbClr val="1A1A1A"/>
                 </a:solidFill>
                 <a:latin typeface="Arial"/>
                 <a:cs typeface="Arial" pitchFamily="34" charset="0"/>
               </a:rPr>
-              <a:t>Students stop guessing why they lost marks. Instead of "72/100" they see "your program crashes when the list is empty" - and which topic to revise because of it.</a:t>
-            </a:r>
-          </a:p>
-          <a:p>
-            <a:pPr algn="just" marL="329184" indent="-219456">
+              <a:t>Students see “your program crashes on an empty list” instead of “72/100”.</a:t>
+            </a:r>
+          </a:p>
+          <a:p>
+            <a:pPr algn="l" marL="329184" indent="-219456">
               <a:lnSpc>
-                <a:spcPct val="95000"/>
+                <a:spcPct val="118000"/>
               </a:lnSpc>
               <a:buFont typeface="Arial" pitchFamily="34" charset="0"/>
               <a:buChar char="•"/>
               <a:spcAft>
-                <a:spcPts val="200"/>
+                <a:spcPts val="1300"/>
               </a:spcAft>
             </a:pPr>
             <a:r>
-              <a:rPr sz="1500" b="0" i="0" u="none">
+              <a:rPr sz="1750" b="0" i="0" u="none">
                 <a:solidFill>
                   <a:srgbClr val="1A1A1A"/>
                 </a:solidFill>
                 <a:latin typeface="Arial"/>
                 <a:cs typeface="Arial" pitchFamily="34" charset="0"/>
               </a:rPr>
-              <a:t>Teachers get their marking hours back, and get told what the class did not understand while there is still time to teach it again.</a:t>
-            </a:r>
-          </a:p>
-          <a:p>
-            <a:pPr algn="just" marL="329184" indent="-219456">
+              <a:t>Teachers get their marking hours back, and hear what the class missed in time to teach it again.</a:t>
+            </a:r>
+          </a:p>
+          <a:p>
+            <a:pPr algn="l" marL="329184" indent="-219456">
               <a:lnSpc>
-                <a:spcPct val="95000"/>
+                <a:spcPct val="118000"/>
               </a:lnSpc>
               <a:buFont typeface="Arial" pitchFamily="34" charset="0"/>
               <a:buChar char="•"/>
               <a:spcAft>
-                <a:spcPts val="200"/>
+                <a:spcPts val="1300"/>
               </a:spcAft>
             </a:pPr>
             <a:r>
-              <a:rPr sz="1500" b="0" i="0" u="none">
+              <a:rPr sz="1750" b="0" i="0" u="none">
                 <a:solidFill>
                   <a:srgbClr val="1A1A1A"/>
                 </a:solidFill>
                 <a:latin typeface="Arial"/>
                 <a:cs typeface="Arial" pitchFamily="34" charset="0"/>
               </a:rPr>
-              <a:t>Heads of department see how the course is performing against its stated outcomes, live, instead of reconstructing it at the end of the year.</a:t>
+              <a:t>Departments get NBA and NAAC outcome reports that are always up to date.</a:t>
             </a:r>
           </a:p>
           <a:p>
@@ -8739,14 +8717,14 @@
               <a:buFont typeface="Wingdings" pitchFamily="34" charset="0"/>
               <a:buChar char="v"/>
               <a:spcBef>
-                <a:spcPts val="700"/>
+                <a:spcPts val="3400"/>
               </a:spcBef>
               <a:spcAft>
-                <a:spcPts val="300"/>
+                <a:spcPts val="600"/>
               </a:spcAft>
             </a:pPr>
             <a:r>
-              <a:rPr sz="1700" b="1" i="0" u="sng">
+              <a:rPr sz="2000" b="1" i="0" u="sng">
                 <a:solidFill>
                   <a:srgbClr val="1F497D"/>
                 </a:solidFill>
@@ -8757,91 +8735,91 @@
             </a:r>
           </a:p>
           <a:p>
-            <a:pPr algn="just" marL="329184" indent="-219456">
+            <a:pPr algn="l" marL="329184" indent="-219456">
               <a:lnSpc>
-                <a:spcPct val="95000"/>
+                <a:spcPct val="118000"/>
               </a:lnSpc>
               <a:buFont typeface="Arial" pitchFamily="34" charset="0"/>
               <a:buChar char="•"/>
               <a:spcAft>
-                <a:spcPts val="200"/>
+                <a:spcPts val="1300"/>
               </a:spcAft>
             </a:pPr>
             <a:r>
-              <a:rPr sz="1500" b="0" i="0" u="none">
+              <a:rPr sz="1750" b="0" i="0" u="none">
                 <a:solidFill>
                   <a:srgbClr val="1A1A1A"/>
                 </a:solidFill>
                 <a:latin typeface="Arial"/>
                 <a:cs typeface="Arial" pitchFamily="34" charset="0"/>
               </a:rPr>
-              <a:t>Fairer marking. Every student is marked to the same standard, every mark comes with a reason, and any student can question any mark.</a:t>
-            </a:r>
-          </a:p>
-          <a:p>
-            <a:pPr algn="just" marL="329184" indent="-219456">
+              <a:t>Fairer - one standard for everyone, every mark has a reason, every mark can be questioned.</a:t>
+            </a:r>
+          </a:p>
+          <a:p>
+            <a:pPr algn="l" marL="329184" indent="-219456">
               <a:lnSpc>
-                <a:spcPct val="95000"/>
+                <a:spcPct val="118000"/>
               </a:lnSpc>
               <a:buFont typeface="Arial" pitchFamily="34" charset="0"/>
               <a:buChar char="•"/>
               <a:spcAft>
-                <a:spcPts val="200"/>
+                <a:spcPts val="1300"/>
               </a:spcAft>
             </a:pPr>
             <a:r>
-              <a:rPr sz="1500" b="0" i="0" u="none">
+              <a:rPr sz="1750" b="0" i="0" u="none">
                 <a:solidFill>
                   <a:srgbClr val="1A1A1A"/>
                 </a:solidFill>
                 <a:latin typeface="Arial"/>
                 <a:cs typeface="Arial" pitchFamily="34" charset="0"/>
               </a:rPr>
-              <a:t>Time and cost saved. Marking a lab of sixty students goes from an evening's work to reviewing the handful the system was unsure about.</a:t>
-            </a:r>
-          </a:p>
-          <a:p>
-            <a:pPr algn="just" marL="329184" indent="-219456">
+              <a:t>Cheaper - an evening of marking becomes reviewing the few cases the system flagged.</a:t>
+            </a:r>
+          </a:p>
+          <a:p>
+            <a:pPr algn="l" marL="329184" indent="-219456">
               <a:lnSpc>
-                <a:spcPct val="95000"/>
+                <a:spcPct val="118000"/>
               </a:lnSpc>
               <a:buFont typeface="Arial" pitchFamily="34" charset="0"/>
               <a:buChar char="•"/>
               <a:spcAft>
-                <a:spcPts val="200"/>
+                <a:spcPts val="1300"/>
               </a:spcAft>
             </a:pPr>
             <a:r>
-              <a:rPr sz="1500" b="0" i="0" u="none">
+              <a:rPr sz="1750" b="0" i="0" u="none">
                 <a:solidFill>
                   <a:srgbClr val="1A1A1A"/>
                 </a:solidFill>
                 <a:latin typeface="Arial"/>
                 <a:cs typeface="Arial" pitchFamily="34" charset="0"/>
               </a:rPr>
-              <a:t>Accreditation reporting for NBA and NAAC, which takes weeks of manual work today, becomes a report that is always up to date.</a:t>
-            </a:r>
-          </a:p>
-          <a:p>
-            <a:pPr algn="just" marL="329184" indent="-219456">
+              <a:t>Earlier - struggling students are found while something can still be done about it.</a:t>
+            </a:r>
+          </a:p>
+          <a:p>
+            <a:pPr algn="l" marL="329184" indent="-219456">
               <a:lnSpc>
-                <a:spcPct val="95000"/>
+                <a:spcPct val="118000"/>
               </a:lnSpc>
               <a:buFont typeface="Arial" pitchFamily="34" charset="0"/>
               <a:buChar char="•"/>
               <a:spcAft>
-                <a:spcPts val="200"/>
+                <a:spcPts val="1300"/>
               </a:spcAft>
             </a:pPr>
             <a:r>
-              <a:rPr sz="1500" b="0" i="0" u="none">
+              <a:rPr sz="1750" b="0" i="0" u="none">
                 <a:solidFill>
                   <a:srgbClr val="1A1A1A"/>
                 </a:solidFill>
                 <a:latin typeface="Arial"/>
                 <a:cs typeface="Arial" pitchFamily="34" charset="0"/>
               </a:rPr>
-              <a:t>Weaker students are spotted early and offered help, rather than discovered at the end of the semester when nothing can be done.</a:t>
+              <a:t>Lasting - what a class got wrong this year improves how it is taught next year.</a:t>
             </a:r>
           </a:p>
         </p:txBody>
@@ -9227,8 +9205,8 @@
         </p:nvSpPr>
         <p:spPr bwMode="auto">
           <a:xfrm>
-            <a:off x="329184" y="1152144"/>
-            <a:ext cx="11503152" cy="4261104"/>
+            <a:off x="329184" y="1188720"/>
+            <a:ext cx="11503152" cy="4206240"/>
           </a:xfrm>
           <a:prstGeom prst="rect">
             <a:avLst/>
@@ -9252,11 +9230,11 @@
               <a:buFont typeface="Wingdings" pitchFamily="34" charset="0"/>
               <a:buChar char="v"/>
               <a:spcAft>
-                <a:spcPts val="900"/>
+                <a:spcPts val="1000"/>
               </a:spcAft>
             </a:pPr>
             <a:r>
-              <a:rPr sz="1700" b="1" i="0" u="sng">
+              <a:rPr sz="1600" b="1" i="0" u="sng">
                 <a:solidFill>
                   <a:srgbClr val="1F497D"/>
                 </a:solidFill>
@@ -9269,19 +9247,19 @@
           <a:p>
             <a:pPr algn="l" marL="219456" indent="-219456">
               <a:lnSpc>
-                <a:spcPct val="95000"/>
+                <a:spcPct val="106000"/>
               </a:lnSpc>
               <a:buFont typeface="Arial" pitchFamily="34" charset="0"/>
               <a:buChar char="•"/>
               <a:spcBef>
-                <a:spcPts val="500"/>
+                <a:spcPts val="1300"/>
               </a:spcBef>
               <a:spcAft>
-                <a:spcPts val="200"/>
+                <a:spcPts val="500"/>
               </a:spcAft>
             </a:pPr>
             <a:r>
-              <a:rPr sz="1400" b="1" i="0" u="none">
+              <a:rPr sz="1500" b="1" i="0" u="none">
                 <a:solidFill>
                   <a:srgbClr val="0070C0"/>
                 </a:solidFill>
@@ -9294,41 +9272,41 @@
           <a:p>
             <a:pPr algn="l" marL="493776" indent="-219456">
               <a:lnSpc>
-                <a:spcPct val="95000"/>
+                <a:spcPct val="108000"/>
               </a:lnSpc>
               <a:buFont typeface="Arial" pitchFamily="34" charset="0"/>
               <a:buChar char="–"/>
               <a:spcAft>
-                <a:spcPts val="300"/>
+                <a:spcPts val="500"/>
               </a:spcAft>
             </a:pPr>
             <a:r>
-              <a:rPr sz="1250" b="0" i="0" u="none">
+              <a:rPr sz="1300" b="0" i="0" u="none">
                 <a:solidFill>
                   <a:srgbClr val="1A1A1A"/>
                 </a:solidFill>
                 <a:latin typeface="Arial"/>
                 <a:cs typeface="Arial" pitchFamily="34" charset="0"/>
               </a:rPr>
-              <a:t>Schleimer, Wilkerson &amp; Aiken, "Winnowing: Local Algorithms for Document Fingerprinting", ACM SIGMOD 2003 - the method behind MOSS, used by universities worldwide.</a:t>
+              <a:t>Schleimer, Wilkerson &amp; Aiken, “Winnowing: Local Algorithms for Document Fingerprinting”, ACM SIGMOD 2003 - the method behind MOSS.</a:t>
             </a:r>
           </a:p>
           <a:p>
             <a:pPr algn="l" marL="219456" indent="-219456">
               <a:lnSpc>
-                <a:spcPct val="95000"/>
+                <a:spcPct val="106000"/>
               </a:lnSpc>
               <a:buFont typeface="Arial" pitchFamily="34" charset="0"/>
               <a:buChar char="•"/>
               <a:spcBef>
-                <a:spcPts val="500"/>
+                <a:spcPts val="1300"/>
               </a:spcBef>
               <a:spcAft>
-                <a:spcPts val="200"/>
+                <a:spcPts val="500"/>
               </a:spcAft>
             </a:pPr>
             <a:r>
-              <a:rPr sz="1400" b="1" i="0" u="none">
+              <a:rPr sz="1500" b="1" i="0" u="none">
                 <a:solidFill>
                   <a:srgbClr val="0070C0"/>
                 </a:solidFill>
@@ -9341,63 +9319,63 @@
           <a:p>
             <a:pPr algn="l" marL="493776" indent="-219456">
               <a:lnSpc>
-                <a:spcPct val="95000"/>
+                <a:spcPct val="108000"/>
               </a:lnSpc>
               <a:buFont typeface="Arial" pitchFamily="34" charset="0"/>
               <a:buChar char="–"/>
               <a:spcAft>
-                <a:spcPts val="300"/>
+                <a:spcPts val="500"/>
               </a:spcAft>
             </a:pPr>
             <a:r>
-              <a:rPr sz="1250" b="0" i="0" u="none">
+              <a:rPr sz="1300" b="0" i="0" u="none">
                 <a:solidFill>
                   <a:srgbClr val="1A1A1A"/>
                 </a:solidFill>
                 <a:latin typeface="Arial"/>
                 <a:cs typeface="Arial" pitchFamily="34" charset="0"/>
               </a:rPr>
-              <a:t>Corbett &amp; Anderson, "Knowledge Tracing", User Modeling and User-Adapted Interaction, 1994 - the standard model for estimating mastery from performance.</a:t>
+              <a:t>Corbett &amp; Anderson, “Knowledge Tracing”, User Modeling and User-Adapted Interaction, 1994.</a:t>
             </a:r>
           </a:p>
           <a:p>
             <a:pPr algn="l" marL="493776" indent="-219456">
               <a:lnSpc>
-                <a:spcPct val="95000"/>
+                <a:spcPct val="108000"/>
               </a:lnSpc>
               <a:buFont typeface="Arial" pitchFamily="34" charset="0"/>
               <a:buChar char="–"/>
               <a:spcAft>
-                <a:spcPts val="300"/>
+                <a:spcPts val="500"/>
               </a:spcAft>
             </a:pPr>
             <a:r>
-              <a:rPr sz="1250" b="0" i="0" u="none">
+              <a:rPr sz="1300" b="0" i="0" u="none">
                 <a:solidFill>
                   <a:srgbClr val="1A1A1A"/>
                 </a:solidFill>
                 <a:latin typeface="Arial"/>
                 <a:cs typeface="Arial" pitchFamily="34" charset="0"/>
               </a:rPr>
-              <a:t>Ebel &amp; Frisbie, Essentials of Educational Measurement - the classical way to tell a good exam question from a bad one.</a:t>
+              <a:t>Ebel &amp; Frisbie, Essentials of Educational Measurement - telling a good exam question from a bad one.</a:t>
             </a:r>
           </a:p>
           <a:p>
             <a:pPr algn="l" marL="219456" indent="-219456">
               <a:lnSpc>
-                <a:spcPct val="95000"/>
+                <a:spcPct val="106000"/>
               </a:lnSpc>
               <a:buFont typeface="Arial" pitchFamily="34" charset="0"/>
               <a:buChar char="•"/>
               <a:spcBef>
-                <a:spcPts val="500"/>
+                <a:spcPts val="1300"/>
               </a:spcBef>
               <a:spcAft>
-                <a:spcPts val="200"/>
+                <a:spcPts val="500"/>
               </a:spcAft>
             </a:pPr>
             <a:r>
-              <a:rPr sz="1400" b="1" i="0" u="none">
+              <a:rPr sz="1500" b="1" i="0" u="none">
                 <a:solidFill>
                   <a:srgbClr val="0070C0"/>
                 </a:solidFill>
@@ -9410,161 +9388,114 @@
           <a:p>
             <a:pPr algn="l" marL="493776" indent="-219456">
               <a:lnSpc>
-                <a:spcPct val="95000"/>
+                <a:spcPct val="108000"/>
               </a:lnSpc>
               <a:buFont typeface="Arial" pitchFamily="34" charset="0"/>
               <a:buChar char="–"/>
               <a:spcAft>
-                <a:spcPts val="300"/>
+                <a:spcPts val="500"/>
               </a:spcAft>
             </a:pPr>
             <a:r>
-              <a:rPr sz="1250" b="0" i="0" u="none">
+              <a:rPr sz="1300" b="0" i="0" u="none">
                 <a:solidFill>
                   <a:srgbClr val="1A1A1A"/>
                 </a:solidFill>
                 <a:latin typeface="Arial"/>
                 <a:cs typeface="Arial" pitchFamily="34" charset="0"/>
               </a:rPr>
-              <a:t>Gulwani, Radicek &amp; Zuleger, "Automated Clustering and Program Repair for Introductory Programming Assignments", PLDI 2018 - the basis for giving partial credit instead of a zero.</a:t>
+              <a:t>Gulwani, Radicek &amp; Zuleger, “Automated Clustering and Program Repair for Introductory Programming Assignments”, PLDI 2018.</a:t>
             </a:r>
           </a:p>
           <a:p>
             <a:pPr algn="l" marL="493776" indent="-219456">
               <a:lnSpc>
-                <a:spcPct val="95000"/>
+                <a:spcPct val="108000"/>
               </a:lnSpc>
               <a:buFont typeface="Arial" pitchFamily="34" charset="0"/>
               <a:buChar char="–"/>
               <a:spcAft>
-                <a:spcPts val="300"/>
+                <a:spcPts val="500"/>
               </a:spcAft>
             </a:pPr>
             <a:r>
-              <a:rPr sz="1250" b="0" i="0" u="none">
+              <a:rPr sz="1300" b="0" i="0" u="none">
                 <a:solidFill>
                   <a:srgbClr val="1A1A1A"/>
                 </a:solidFill>
                 <a:latin typeface="Arial"/>
                 <a:cs typeface="Arial" pitchFamily="34" charset="0"/>
               </a:rPr>
-              <a:t>tree-sitter - the parser used to understand student code even when it does not compile.</a:t>
+              <a:t>tree-sitter - the parser used to read student code even when it does not compile.</a:t>
             </a:r>
           </a:p>
           <a:p>
             <a:pPr algn="l" marL="219456" indent="-219456">
               <a:lnSpc>
-                <a:spcPct val="95000"/>
+                <a:spcPct val="106000"/>
               </a:lnSpc>
               <a:buFont typeface="Arial" pitchFamily="34" charset="0"/>
               <a:buChar char="•"/>
               <a:spcBef>
-                <a:spcPts val="500"/>
+                <a:spcPts val="1300"/>
               </a:spcBef>
               <a:spcAft>
-                <a:spcPts val="200"/>
+                <a:spcPts val="500"/>
               </a:spcAft>
             </a:pPr>
             <a:r>
-              <a:rPr sz="1400" b="1" i="0" u="none">
+              <a:rPr sz="1500" b="1" i="0" u="none">
                 <a:solidFill>
                   <a:srgbClr val="0070C0"/>
                 </a:solidFill>
                 <a:latin typeface="Arial"/>
                 <a:cs typeface="Arial" pitchFamily="34" charset="0"/>
               </a:rPr>
-              <a:t>Running untrusted code safely</a:t>
+              <a:t>Running untrusted code, and the standards we build to</a:t>
             </a:r>
           </a:p>
           <a:p>
             <a:pPr algn="l" marL="493776" indent="-219456">
               <a:lnSpc>
-                <a:spcPct val="95000"/>
+                <a:spcPct val="108000"/>
               </a:lnSpc>
               <a:buFont typeface="Arial" pitchFamily="34" charset="0"/>
               <a:buChar char="–"/>
               <a:spcAft>
-                <a:spcPts val="300"/>
+                <a:spcPts val="500"/>
               </a:spcAft>
             </a:pPr>
             <a:r>
-              <a:rPr sz="1250" b="0" i="0" u="none">
+              <a:rPr sz="1300" b="0" i="0" u="none">
                 <a:solidFill>
                   <a:srgbClr val="1A1A1A"/>
                 </a:solidFill>
                 <a:latin typeface="Arial"/>
                 <a:cs typeface="Arial" pitchFamily="34" charset="0"/>
               </a:rPr>
-              <a:t>Agache et al., "Firecracker: Lightweight Virtualization", USENIX NSDI 2020.</a:t>
-            </a:r>
-          </a:p>
-          <a:p>
-            <a:pPr algn="l" marL="219456" indent="-219456">
-              <a:lnSpc>
-                <a:spcPct val="95000"/>
-              </a:lnSpc>
-              <a:buFont typeface="Arial" pitchFamily="34" charset="0"/>
-              <a:buChar char="•"/>
-              <a:spcBef>
-                <a:spcPts val="500"/>
-              </a:spcBef>
-              <a:spcAft>
-                <a:spcPts val="200"/>
-              </a:spcAft>
-            </a:pPr>
-            <a:r>
-              <a:rPr sz="1400" b="1" i="0" u="none">
-                <a:solidFill>
-                  <a:srgbClr val="0070C0"/>
-                </a:solidFill>
-                <a:latin typeface="Arial"/>
-                <a:cs typeface="Arial" pitchFamily="34" charset="0"/>
-              </a:rPr>
-              <a:t>Standards we build to</a:t>
+              <a:t>Agache et al., “Firecracker: Lightweight Virtualization”, USENIX NSDI 2020.</a:t>
             </a:r>
           </a:p>
           <a:p>
             <a:pPr algn="l" marL="493776" indent="-219456">
               <a:lnSpc>
-                <a:spcPct val="95000"/>
+                <a:spcPct val="108000"/>
               </a:lnSpc>
               <a:buFont typeface="Arial" pitchFamily="34" charset="0"/>
               <a:buChar char="–"/>
               <a:spcAft>
-                <a:spcPts val="300"/>
+                <a:spcPts val="500"/>
               </a:spcAft>
             </a:pPr>
             <a:r>
-              <a:rPr sz="1250" b="0" i="0" u="none">
+              <a:rPr sz="1300" b="0" i="0" u="none">
                 <a:solidFill>
                   <a:srgbClr val="1A1A1A"/>
                 </a:solidFill>
                 <a:latin typeface="Arial"/>
                 <a:cs typeface="Arial" pitchFamily="34" charset="0"/>
               </a:rPr>
-              <a:t>1EdTech Learning Tools Interoperability 1.3 - how the platform plugs into Moodle and Google Classroom.</a:t>
-            </a:r>
-          </a:p>
-          <a:p>
-            <a:pPr algn="l" marL="493776" indent="-219456">
-              <a:lnSpc>
-                <a:spcPct val="95000"/>
-              </a:lnSpc>
-              <a:buFont typeface="Arial" pitchFamily="34" charset="0"/>
-              <a:buChar char="–"/>
-              <a:spcAft>
-                <a:spcPts val="300"/>
-              </a:spcAft>
-            </a:pPr>
-            <a:r>
-              <a:rPr sz="1250" b="0" i="0" u="none">
-                <a:solidFill>
-                  <a:srgbClr val="1A1A1A"/>
-                </a:solidFill>
-                <a:latin typeface="Arial"/>
-                <a:cs typeface="Arial" pitchFamily="34" charset="0"/>
-              </a:rPr>
-              <a:t>National Board of Accreditation (India) - the CO-PO attainment rules the reports follow.</a:t>
+              <a:t>1EdTech LTI 1.3 for Moodle and Google Classroom; NBA (India) for the CO-PO reports.</a:t>
             </a:r>
           </a:p>
         </p:txBody>
@@ -9833,7 +9764,7 @@
           <a:p>
             <a:pPr algn="ctr" marL="0" indent="0">
               <a:lnSpc>
-                <a:spcPct val="95000"/>
+                <a:spcPct val="100000"/>
               </a:lnSpc>
               <a:buNone/>
             </a:pPr>

</xml_diff>

<commit_message>
Put the missing features in the deck
Five things the platform does had no place in the deck. Copying detection
appeared only as a risk to be managed, never as something the platform
offers. The fairness audit that can hold results back was absent entirely.
Grouping the class's mistakes, the early warning on students slipping
behind, and a student's right to challenge a mark were each folded into a
vaguer line or missing.

The vague "tells teachers what to explain again" is now the two concrete
outputs it stood for, and the redundant "tells students what to revise" is
gone - the topic-level bullet above already says it.

Slide 2 verified against a PowerPoint render: every bullet still sits on one
line, inside the margin, clear of the footer.
</commit_message>
<xml_diff>
--- a/presentation/SIH2026-EvalPro-Idea-Presentation.pptx
+++ b/presentation/SIH2026-EvalPro-Idea-Presentation.pptx
@@ -6138,6 +6138,28 @@
             </a:r>
           </a:p>
           <a:p>
+            <a:pPr algn="l" marL="329184" indent="-219456">
+              <a:lnSpc>
+                <a:spcPct val="112000"/>
+              </a:lnSpc>
+              <a:buFont typeface="Arial" pitchFamily="34" charset="0"/>
+              <a:buChar char="•"/>
+              <a:spcAft>
+                <a:spcPts val="600"/>
+              </a:spcAft>
+            </a:pPr>
+            <a:r>
+              <a:rPr sz="1600" b="0" i="0" u="none">
+                <a:solidFill>
+                  <a:srgbClr val="1A1A1A"/>
+                </a:solidFill>
+                <a:latin typeface="Arial"/>
+                <a:cs typeface="Arial" pitchFamily="34" charset="0"/>
+              </a:rPr>
+              <a:t>A student who thinks a mark is wrong can challenge it, and a teacher answers.</a:t>
+            </a:r>
+          </a:p>
+          <a:p>
             <a:pPr algn="l" marL="219456" indent="-219456">
               <a:lnSpc>
                 <a:spcPct val="100000"/>
@@ -6225,7 +6247,29 @@
                 <a:latin typeface="Arial"/>
                 <a:cs typeface="Arial" pitchFamily="34" charset="0"/>
               </a:rPr>
-              <a:t>Tells students what to revise, and teachers what to explain again.</a:t>
+              <a:t>Groups the class's mistakes, so a teacher sees the few things most people got wrong.</a:t>
+            </a:r>
+          </a:p>
+          <a:p>
+            <a:pPr algn="l" marL="329184" indent="-219456">
+              <a:lnSpc>
+                <a:spcPct val="112000"/>
+              </a:lnSpc>
+              <a:buFont typeface="Arial" pitchFamily="34" charset="0"/>
+              <a:buChar char="•"/>
+              <a:spcAft>
+                <a:spcPts val="600"/>
+              </a:spcAft>
+            </a:pPr>
+            <a:r>
+              <a:rPr sz="1600" b="0" i="0" u="none">
+                <a:solidFill>
+                  <a:srgbClr val="1A1A1A"/>
+                </a:solidFill>
+                <a:latin typeface="Arial"/>
+                <a:cs typeface="Arial" pitchFamily="34" charset="0"/>
+              </a:rPr>
+              <a:t>Flags students slipping behind while there is still time to help them.</a:t>
             </a:r>
           </a:p>
           <a:p>
@@ -6317,6 +6361,50 @@
                 <a:cs typeface="Arial" pitchFamily="34" charset="0"/>
               </a:rPr>
               <a:t>It marks the question paper too - unclear questions are flagged to the teacher.</a:t>
+            </a:r>
+          </a:p>
+          <a:p>
+            <a:pPr algn="l" marL="329184" indent="-219456">
+              <a:lnSpc>
+                <a:spcPct val="112000"/>
+              </a:lnSpc>
+              <a:buFont typeface="Arial" pitchFamily="34" charset="0"/>
+              <a:buChar char="•"/>
+              <a:spcAft>
+                <a:spcPts val="600"/>
+              </a:spcAft>
+            </a:pPr>
+            <a:r>
+              <a:rPr sz="1600" b="0" i="0" u="none">
+                <a:solidFill>
+                  <a:srgbClr val="1A1A1A"/>
+                </a:solidFill>
+                <a:latin typeface="Arial"/>
+                <a:cs typeface="Arial" pitchFamily="34" charset="0"/>
+              </a:rPr>
+              <a:t>It spots copied work by showing the matching lines - the teacher decides, not the machine.</a:t>
+            </a:r>
+          </a:p>
+          <a:p>
+            <a:pPr algn="l" marL="329184" indent="-219456">
+              <a:lnSpc>
+                <a:spcPct val="112000"/>
+              </a:lnSpc>
+              <a:buFont typeface="Arial" pitchFamily="34" charset="0"/>
+              <a:buChar char="•"/>
+              <a:spcAft>
+                <a:spcPts val="600"/>
+              </a:spcAft>
+            </a:pPr>
+            <a:r>
+              <a:rPr sz="1600" b="0" i="0" u="none">
+                <a:solidFill>
+                  <a:srgbClr val="1A1A1A"/>
+                </a:solidFill>
+                <a:latin typeface="Arial"/>
+                <a:cs typeface="Arial" pitchFamily="34" charset="0"/>
+              </a:rPr>
+              <a:t>It checks its own fairness: if it marks one group differently, it says so before results go out.</a:t>
             </a:r>
           </a:p>
           <a:p>

</xml_diff>